<commit_message>
Agregar el diseño Monograma claro a los mockups y la presentación
El arte nuevo (patrón gris de JJ y cruces con el contacto de la tienda)
se monta en la bolsa como propuesta 10, entra en la lámina general y en
la presentación: portada, vista general, su diapositiva y la tabla.

Co-Authored-By: Claude Opus 5.5 <noreply@anthropic.com>
Claude-Session: https://claude.ai/code/session_01VnkotToXmrC5jDxRfMqBZq
</commit_message>
<xml_diff>
--- a/bolsa-jdcel/JDCEL-propuestas-bolsa.pptx
+++ b/bolsa-jdcel/JDCEL-propuestas-bolsa.pptx
@@ -18,9 +18,10 @@
     <p:sldId id="266" r:id="rId12"/>
     <p:sldId id="267" r:id="rId13"/>
     <p:sldId id="268" r:id="rId14"/>
+    <p:sldId id="269" r:id="rId15"/>
   </p:sldIdLst>
   <p:notesMasterIdLst>
-    <p:notesMasterId r:id="rId15"/>
+    <p:notesMasterId r:id="rId16"/>
   </p:notesMasterIdLst>
   <p:sldSz cx="12192000" cy="6858000"/>
   <p:notesSz cx="6858000" cy="12192000"/>
@@ -778,7 +779,7 @@
           <a:p>
             <a:r>
               <a:rPr lang="en-US" dirty="0"/>
-              <a:t>Baja: una tinta. Media: blanco sobre cartulina negra. Alta: relieve seco o barniz UV, que necesitan molde o capa aparte. Es una referencia para elegir; los costos los confirma la imprenta.</a:t>
+              <a:t>Monograma claro. La versión clara del patrón de la propuesta 06: monogramas y cruces en gris claro sobre blanco, logo grande y contacto al frente (WhatsApp 3117346937, Instagram jdcelbq_). El gris puede imprimirse como una trama del negro, así que sale con una sola tinta.</a:t>
             </a:r>
             <a:endParaRPr lang="en-US" dirty="0"/>
           </a:p>
@@ -866,7 +867,7 @@
           <a:p>
             <a:r>
               <a:rPr lang="en-US" dirty="0"/>
-              <a:t>El troquel lo entrega la imprenta: sobre él se monta el frente, los fuelles, el reverso y la base. Los frentes están en arte-frente/ (SVG) y en canva/ (para editar en Canva).</a:t>
+              <a:t>Baja: una tinta. Media: blanco sobre cartulina negra. Alta: relieve seco o barniz UV, que necesitan molde o capa aparte. Es una referencia para elegir; los costos los confirma la imprenta.</a:t>
             </a:r>
             <a:endParaRPr lang="en-US" dirty="0"/>
           </a:p>
@@ -890,6 +891,94 @@
             <a:fld id="{F7021451-1387-4CA6-816F-3879F97B5CBC}" type="slidenum">
               <a:rPr lang="en-US"/>
               <a:t>13</a:t>
+            </a:fld>
+            <a:endParaRPr lang="en-US"/>
+          </a:p>
+        </p:txBody>
+      </p:sp>
+    </p:spTree>
+    <p:extLst>
+      <p:ext uri="{BB962C8B-B14F-4D97-AF65-F5344CB8AC3E}">
+        <p14:creationId xmlns:p14="http://schemas.microsoft.com/office/powerpoint/2010/main" val="1024086991"/>
+      </p:ext>
+    </p:extLst>
+  </p:cSld>
+  <p:clrMapOvr>
+    <a:masterClrMapping/>
+  </p:clrMapOvr>
+</p:notes>
+</file>
+
+<file path=ppt/notesSlides/notesSlide14.xml><?xml version="1.0" encoding="utf-8"?>
+<p:notes xmlns:a="http://schemas.openxmlformats.org/drawingml/2006/main" xmlns:r="http://schemas.openxmlformats.org/officeDocument/2006/relationships" xmlns:p="http://schemas.openxmlformats.org/presentationml/2006/main">
+  <p:cSld>
+    <p:spTree>
+      <p:nvGrpSpPr>
+        <p:cNvPr id="1" name=""/>
+        <p:cNvGrpSpPr/>
+        <p:nvPr/>
+      </p:nvGrpSpPr>
+      <p:grpSpPr>
+        <a:xfrm>
+          <a:off x="0" y="0"/>
+          <a:ext cx="0" cy="0"/>
+          <a:chOff x="0" y="0"/>
+          <a:chExt cx="0" cy="0"/>
+        </a:xfrm>
+      </p:grpSpPr>
+      <p:sp>
+        <p:nvSpPr>
+          <p:cNvPr id="2" name="Slide Image Placeholder 1"/>
+          <p:cNvSpPr>
+            <a:spLocks noGrp="1" noRot="1" noChangeAspect="1"/>
+          </p:cNvSpPr>
+          <p:nvPr>
+            <p:ph type="sldImg"/>
+          </p:nvPr>
+        </p:nvSpPr>
+        <p:spPr/>
+      </p:sp>
+      <p:sp>
+        <p:nvSpPr>
+          <p:cNvPr id="3" name="Notes Placeholder 2"/>
+          <p:cNvSpPr>
+            <a:spLocks noGrp="1"/>
+          </p:cNvSpPr>
+          <p:nvPr>
+            <p:ph type="body" idx="1"/>
+          </p:nvPr>
+        </p:nvSpPr>
+        <p:spPr/>
+        <p:txBody>
+          <a:bodyPr/>
+          <a:lstStyle/>
+          <a:p>
+            <a:r>
+              <a:rPr lang="en-US" dirty="0"/>
+              <a:t>El troquel lo entrega la imprenta: sobre él se monta el frente, los fuelles, el reverso y la base. Los frentes están en arte-frente/ (SVG) y en canva/ (para editar en Canva).</a:t>
+            </a:r>
+            <a:endParaRPr lang="en-US" dirty="0"/>
+          </a:p>
+        </p:txBody>
+      </p:sp>
+      <p:sp>
+        <p:nvSpPr>
+          <p:cNvPr id="4" name="Slide Number Placeholder 3"/>
+          <p:cNvSpPr>
+            <a:spLocks noGrp="1"/>
+          </p:cNvSpPr>
+          <p:nvPr>
+            <p:ph type="sldNum" sz="quarter" idx="10"/>
+          </p:nvPr>
+        </p:nvSpPr>
+        <p:spPr/>
+        <p:txBody>
+          <a:bodyPr/>
+          <a:lstStyle/>
+          <a:p>
+            <a:fld id="{F7021451-1387-4CA6-816F-3879F97B5CBC}" type="slidenum">
+              <a:rPr lang="en-US"/>
+              <a:t>14</a:t>
             </a:fld>
             <a:endParaRPr lang="en-US"/>
           </a:p>
@@ -954,7 +1043,7 @@
           <a:p>
             <a:r>
               <a:rPr lang="en-US" dirty="0"/>
-              <a:t>Las ocho primeras son el frente de la bolsa; la 09 es un reverso que se combina con cualquiera. El monograma JJ de las imágenes es aproximado.</a:t>
+              <a:t>Todas son el frente de la bolsa, menos la 09, que es un reverso para combinar con cualquiera. La 10 es el diseño nuevo con el contacto real de la tienda. El monograma JJ de las imágenes es aproximado.</a:t>
             </a:r>
             <a:endParaRPr lang="en-US" dirty="0"/>
           </a:p>
@@ -2143,7 +2232,7 @@
                 <a:ea typeface="Arial" pitchFamily="34" charset="-122"/>
                 <a:cs typeface="Arial" pitchFamily="34" charset="-120"/>
               </a:rPr>
-              <a:t>9 ideas en negro y blanco · frente de 25 × 30 cm</a:t>
+              <a:t>10 ideas en negro y blanco · frente de 25 × 30 cm</a:t>
             </a:r>
             <a:endParaRPr lang="en-US" sz="1200" dirty="0"/>
           </a:p>
@@ -3181,16 +3270,79 @@
           <a:chExt cx="0" cy="0"/>
         </a:xfrm>
       </p:grpSpPr>
-      <p:sp>
-        <p:nvSpPr>
-          <p:cNvPr id="2" name="Text 0"/>
+      <p:pic>
+        <p:nvPicPr>
+          <p:cNvPr id="2" name="Image 0" descr="Bolsa de la propuesta Monograma claro">    </p:cNvPr>
+          <p:cNvPicPr>
+            <a:picLocks noChangeAspect="1"/>
+          </p:cNvPicPr>
+          <p:nvPr/>
+        </p:nvPicPr>
+        <p:blipFill>
+          <a:blip r:embed="rId1"/>
+          <a:stretch>
+            <a:fillRect/>
+          </a:stretch>
+        </p:blipFill>
+        <p:spPr>
+          <a:xfrm>
+            <a:off x="6019495" y="0"/>
+            <a:ext cx="6172200" cy="6858000"/>
+          </a:xfrm>
+          <a:prstGeom prst="rect">
+            <a:avLst/>
+          </a:prstGeom>
+        </p:spPr>
+      </p:pic>
+      <p:sp>
+        <p:nvSpPr>
+          <p:cNvPr id="3" name="Text 0"/>
           <p:cNvSpPr txBox="1"/>
           <p:nvPr/>
         </p:nvSpPr>
         <p:spPr>
           <a:xfrm>
-            <a:off x="548640" y="411480"/>
-            <a:ext cx="7315200" cy="640080"/>
+            <a:off x="548640" y="640080"/>
+            <a:ext cx="4922215" cy="274320"/>
+          </a:xfrm>
+          <a:prstGeom prst="rect">
+            <a:avLst/>
+          </a:prstGeom>
+          <a:noFill/>
+          <a:ln/>
+        </p:spPr>
+        <p:txBody>
+          <a:bodyPr wrap="square" lIns="0" tIns="0" rIns="0" bIns="0" rtlCol="0" anchor="t"/>
+          <a:lstStyle/>
+          <a:p>
+            <a:pPr indent="0" marL="0">
+              <a:buNone/>
+            </a:pPr>
+            <a:r>
+              <a:rPr lang="en-US" sz="1200" b="1" spc="300" kern="0" dirty="0">
+                <a:solidFill>
+                  <a:srgbClr val="6B6B6B"/>
+                </a:solidFill>
+                <a:latin typeface="Arial" pitchFamily="34" charset="0"/>
+                <a:ea typeface="Arial" pitchFamily="34" charset="-122"/>
+                <a:cs typeface="Arial" pitchFamily="34" charset="-120"/>
+              </a:rPr>
+              <a:t>PROPUESTA 10</a:t>
+            </a:r>
+            <a:endParaRPr lang="en-US" sz="1200" dirty="0"/>
+          </a:p>
+        </p:txBody>
+      </p:sp>
+      <p:sp>
+        <p:nvSpPr>
+          <p:cNvPr id="4" name="Text 1"/>
+          <p:cNvSpPr txBox="1"/>
+          <p:nvPr/>
+        </p:nvSpPr>
+        <p:spPr>
+          <a:xfrm>
+            <a:off x="548640" y="932688"/>
+            <a:ext cx="4922215" cy="731520"/>
           </a:xfrm>
           <a:prstGeom prst="rect">
             <a:avLst/>
@@ -3214,6 +3366,443 @@
                 <a:ea typeface="Georgia" pitchFamily="34" charset="-122"/>
                 <a:cs typeface="Georgia" pitchFamily="34" charset="-120"/>
               </a:rPr>
+              <a:t>Monograma claro</a:t>
+            </a:r>
+            <a:endParaRPr lang="en-US" sz="3600" dirty="0"/>
+          </a:p>
+        </p:txBody>
+      </p:sp>
+      <p:sp>
+        <p:nvSpPr>
+          <p:cNvPr id="5" name="Text 2"/>
+          <p:cNvSpPr txBox="1"/>
+          <p:nvPr/>
+        </p:nvSpPr>
+        <p:spPr>
+          <a:xfrm>
+            <a:off x="548640" y="1828800"/>
+            <a:ext cx="4922215" cy="1417320"/>
+          </a:xfrm>
+          <a:prstGeom prst="rect">
+            <a:avLst/>
+          </a:prstGeom>
+          <a:noFill/>
+          <a:ln/>
+        </p:spPr>
+        <p:txBody>
+          <a:bodyPr wrap="square" lIns="0" tIns="0" rIns="0" bIns="0" rtlCol="0" anchor="t"/>
+          <a:lstStyle/>
+          <a:p>
+            <a:pPr indent="0" marL="0">
+              <a:lnSpc>
+                <a:spcPct val="115000"/>
+              </a:lnSpc>
+              <a:buNone/>
+            </a:pPr>
+            <a:r>
+              <a:rPr lang="en-US" sz="1500" dirty="0">
+                <a:solidFill>
+                  <a:srgbClr val="111111"/>
+                </a:solidFill>
+                <a:latin typeface="Arial" pitchFamily="34" charset="0"/>
+                <a:ea typeface="Arial" pitchFamily="34" charset="-122"/>
+                <a:cs typeface="Arial" pitchFamily="34" charset="-120"/>
+              </a:rPr>
+              <a:t>La versión clara del monograma: un patrón gris de JJ y cruces cubre la bolsa blanca, con el logo grande y el WhatsApp y el Instagram de la tienda al frente.</a:t>
+            </a:r>
+            <a:endParaRPr lang="en-US" sz="1500" dirty="0"/>
+          </a:p>
+        </p:txBody>
+      </p:sp>
+      <p:pic>
+        <p:nvPicPr>
+          <p:cNvPr id="6" name="Image 1" descr="Arte del frente de la propuesta Monograma claro">    </p:cNvPr>
+          <p:cNvPicPr>
+            <a:picLocks noChangeAspect="1"/>
+          </p:cNvPicPr>
+          <p:nvPr/>
+        </p:nvPicPr>
+        <p:blipFill>
+          <a:blip r:embed="rId2"/>
+          <a:stretch>
+            <a:fillRect/>
+          </a:stretch>
+        </p:blipFill>
+        <p:spPr>
+          <a:xfrm>
+            <a:off x="548640" y="3520440"/>
+            <a:ext cx="2057400" cy="2468880"/>
+          </a:xfrm>
+          <a:prstGeom prst="rect">
+            <a:avLst/>
+          </a:prstGeom>
+        </p:spPr>
+      </p:pic>
+      <p:sp>
+        <p:nvSpPr>
+          <p:cNvPr id="7" name="Shape 3"/>
+          <p:cNvSpPr/>
+          <p:nvPr/>
+        </p:nvSpPr>
+        <p:spPr>
+          <a:xfrm>
+            <a:off x="548640" y="3520440"/>
+            <a:ext cx="2057400" cy="2468880"/>
+          </a:xfrm>
+          <a:prstGeom prst="rect">
+            <a:avLst/>
+          </a:prstGeom>
+          <a:solidFill>
+            <a:srgbClr val="FFFFFF">
+              <a:alpha val="0"/>
+            </a:srgbClr>
+          </a:solidFill>
+          <a:ln w="9525">
+            <a:solidFill>
+              <a:srgbClr val="D9D9D9"/>
+            </a:solidFill>
+            <a:prstDash val="solid"/>
+          </a:ln>
+        </p:spPr>
+      </p:sp>
+      <p:sp>
+        <p:nvSpPr>
+          <p:cNvPr id="8" name="Text 4"/>
+          <p:cNvSpPr txBox="1"/>
+          <p:nvPr/>
+        </p:nvSpPr>
+        <p:spPr>
+          <a:xfrm>
+            <a:off x="548640" y="6062472"/>
+            <a:ext cx="2514600" cy="256032"/>
+          </a:xfrm>
+          <a:prstGeom prst="rect">
+            <a:avLst/>
+          </a:prstGeom>
+          <a:noFill/>
+          <a:ln/>
+        </p:spPr>
+        <p:txBody>
+          <a:bodyPr wrap="square" lIns="0" tIns="0" rIns="0" bIns="0" rtlCol="0" anchor="t"/>
+          <a:lstStyle/>
+          <a:p>
+            <a:pPr indent="0" marL="0">
+              <a:buNone/>
+            </a:pPr>
+            <a:r>
+              <a:rPr lang="en-US" sz="1000" dirty="0">
+                <a:solidFill>
+                  <a:srgbClr val="6B6B6B"/>
+                </a:solidFill>
+                <a:latin typeface="Arial" pitchFamily="34" charset="0"/>
+                <a:ea typeface="Arial" pitchFamily="34" charset="-122"/>
+                <a:cs typeface="Arial" pitchFamily="34" charset="-120"/>
+              </a:rPr>
+              <a:t>Arte del frente · 25 × 30 cm</a:t>
+            </a:r>
+            <a:endParaRPr lang="en-US" sz="1000" dirty="0"/>
+          </a:p>
+        </p:txBody>
+      </p:sp>
+      <p:sp>
+        <p:nvSpPr>
+          <p:cNvPr id="9" name="Text 5"/>
+          <p:cNvSpPr txBox="1"/>
+          <p:nvPr/>
+        </p:nvSpPr>
+        <p:spPr>
+          <a:xfrm>
+            <a:off x="2971800" y="3520440"/>
+            <a:ext cx="2499055" cy="228600"/>
+          </a:xfrm>
+          <a:prstGeom prst="rect">
+            <a:avLst/>
+          </a:prstGeom>
+          <a:noFill/>
+          <a:ln/>
+        </p:spPr>
+        <p:txBody>
+          <a:bodyPr wrap="square" lIns="0" tIns="0" rIns="0" bIns="0" rtlCol="0" anchor="t"/>
+          <a:lstStyle/>
+          <a:p>
+            <a:pPr indent="0" marL="0">
+              <a:buNone/>
+            </a:pPr>
+            <a:r>
+              <a:rPr lang="en-US" sz="1000" b="1" spc="150" kern="0" dirty="0">
+                <a:solidFill>
+                  <a:srgbClr val="6B6B6B"/>
+                </a:solidFill>
+                <a:latin typeface="Arial" pitchFamily="34" charset="0"/>
+                <a:ea typeface="Arial" pitchFamily="34" charset="-122"/>
+                <a:cs typeface="Arial" pitchFamily="34" charset="-120"/>
+              </a:rPr>
+              <a:t>BOLSA</a:t>
+            </a:r>
+            <a:endParaRPr lang="en-US" sz="1000" dirty="0"/>
+          </a:p>
+        </p:txBody>
+      </p:sp>
+      <p:sp>
+        <p:nvSpPr>
+          <p:cNvPr id="10" name="Text 6"/>
+          <p:cNvSpPr txBox="1"/>
+          <p:nvPr/>
+        </p:nvSpPr>
+        <p:spPr>
+          <a:xfrm>
+            <a:off x="2971800" y="3767328"/>
+            <a:ext cx="2499055" cy="566928"/>
+          </a:xfrm>
+          <a:prstGeom prst="rect">
+            <a:avLst/>
+          </a:prstGeom>
+          <a:noFill/>
+          <a:ln/>
+        </p:spPr>
+        <p:txBody>
+          <a:bodyPr wrap="square" lIns="0" tIns="0" rIns="0" bIns="0" rtlCol="0" anchor="t"/>
+          <a:lstStyle/>
+          <a:p>
+            <a:pPr indent="0" marL="0">
+              <a:buNone/>
+            </a:pPr>
+            <a:r>
+              <a:rPr lang="en-US" sz="1300" dirty="0">
+                <a:solidFill>
+                  <a:srgbClr val="111111"/>
+                </a:solidFill>
+                <a:latin typeface="Arial" pitchFamily="34" charset="0"/>
+                <a:ea typeface="Arial" pitchFamily="34" charset="-122"/>
+                <a:cs typeface="Arial" pitchFamily="34" charset="-120"/>
+              </a:rPr>
+              <a:t>Blanca</a:t>
+            </a:r>
+            <a:endParaRPr lang="en-US" sz="1300" dirty="0"/>
+          </a:p>
+        </p:txBody>
+      </p:sp>
+      <p:sp>
+        <p:nvSpPr>
+          <p:cNvPr id="11" name="Text 7"/>
+          <p:cNvSpPr txBox="1"/>
+          <p:nvPr/>
+        </p:nvSpPr>
+        <p:spPr>
+          <a:xfrm>
+            <a:off x="2971800" y="4416552"/>
+            <a:ext cx="2499055" cy="228600"/>
+          </a:xfrm>
+          <a:prstGeom prst="rect">
+            <a:avLst/>
+          </a:prstGeom>
+          <a:noFill/>
+          <a:ln/>
+        </p:spPr>
+        <p:txBody>
+          <a:bodyPr wrap="square" lIns="0" tIns="0" rIns="0" bIns="0" rtlCol="0" anchor="t"/>
+          <a:lstStyle/>
+          <a:p>
+            <a:pPr indent="0" marL="0">
+              <a:buNone/>
+            </a:pPr>
+            <a:r>
+              <a:rPr lang="en-US" sz="1000" b="1" spc="150" kern="0" dirty="0">
+                <a:solidFill>
+                  <a:srgbClr val="6B6B6B"/>
+                </a:solidFill>
+                <a:latin typeface="Arial" pitchFamily="34" charset="0"/>
+                <a:ea typeface="Arial" pitchFamily="34" charset="-122"/>
+                <a:cs typeface="Arial" pitchFamily="34" charset="-120"/>
+              </a:rPr>
+              <a:t>IMPRESIÓN</a:t>
+            </a:r>
+            <a:endParaRPr lang="en-US" sz="1000" dirty="0"/>
+          </a:p>
+        </p:txBody>
+      </p:sp>
+      <p:sp>
+        <p:nvSpPr>
+          <p:cNvPr id="12" name="Text 8"/>
+          <p:cNvSpPr txBox="1"/>
+          <p:nvPr/>
+        </p:nvSpPr>
+        <p:spPr>
+          <a:xfrm>
+            <a:off x="2971800" y="4663440"/>
+            <a:ext cx="2499055" cy="566928"/>
+          </a:xfrm>
+          <a:prstGeom prst="rect">
+            <a:avLst/>
+          </a:prstGeom>
+          <a:noFill/>
+          <a:ln/>
+        </p:spPr>
+        <p:txBody>
+          <a:bodyPr wrap="square" lIns="0" tIns="0" rIns="0" bIns="0" rtlCol="0" anchor="t"/>
+          <a:lstStyle/>
+          <a:p>
+            <a:pPr indent="0" marL="0">
+              <a:buNone/>
+            </a:pPr>
+            <a:r>
+              <a:rPr lang="en-US" sz="1300" dirty="0">
+                <a:solidFill>
+                  <a:srgbClr val="111111"/>
+                </a:solidFill>
+                <a:latin typeface="Arial" pitchFamily="34" charset="0"/>
+                <a:ea typeface="Arial" pitchFamily="34" charset="-122"/>
+                <a:cs typeface="Arial" pitchFamily="34" charset="-120"/>
+              </a:rPr>
+              <a:t>Negro y gris claro (el gris sale de una trama del negro)</a:t>
+            </a:r>
+            <a:endParaRPr lang="en-US" sz="1300" dirty="0"/>
+          </a:p>
+        </p:txBody>
+      </p:sp>
+      <p:sp>
+        <p:nvSpPr>
+          <p:cNvPr id="13" name="Text 9"/>
+          <p:cNvSpPr txBox="1"/>
+          <p:nvPr/>
+        </p:nvSpPr>
+        <p:spPr>
+          <a:xfrm>
+            <a:off x="2971800" y="5312664"/>
+            <a:ext cx="2499055" cy="228600"/>
+          </a:xfrm>
+          <a:prstGeom prst="rect">
+            <a:avLst/>
+          </a:prstGeom>
+          <a:noFill/>
+          <a:ln/>
+        </p:spPr>
+        <p:txBody>
+          <a:bodyPr wrap="square" lIns="0" tIns="0" rIns="0" bIns="0" rtlCol="0" anchor="t"/>
+          <a:lstStyle/>
+          <a:p>
+            <a:pPr indent="0" marL="0">
+              <a:buNone/>
+            </a:pPr>
+            <a:r>
+              <a:rPr lang="en-US" sz="1000" b="1" spc="150" kern="0" dirty="0">
+                <a:solidFill>
+                  <a:srgbClr val="6B6B6B"/>
+                </a:solidFill>
+                <a:latin typeface="Arial" pitchFamily="34" charset="0"/>
+                <a:ea typeface="Arial" pitchFamily="34" charset="-122"/>
+                <a:cs typeface="Arial" pitchFamily="34" charset="-120"/>
+              </a:rPr>
+              <a:t>MANIJAS</a:t>
+            </a:r>
+            <a:endParaRPr lang="en-US" sz="1000" dirty="0"/>
+          </a:p>
+        </p:txBody>
+      </p:sp>
+      <p:sp>
+        <p:nvSpPr>
+          <p:cNvPr id="14" name="Text 10"/>
+          <p:cNvSpPr txBox="1"/>
+          <p:nvPr/>
+        </p:nvSpPr>
+        <p:spPr>
+          <a:xfrm>
+            <a:off x="2971800" y="5559552"/>
+            <a:ext cx="2499055" cy="566928"/>
+          </a:xfrm>
+          <a:prstGeom prst="rect">
+            <a:avLst/>
+          </a:prstGeom>
+          <a:noFill/>
+          <a:ln/>
+        </p:spPr>
+        <p:txBody>
+          <a:bodyPr wrap="square" lIns="0" tIns="0" rIns="0" bIns="0" rtlCol="0" anchor="t"/>
+          <a:lstStyle/>
+          <a:p>
+            <a:pPr indent="0" marL="0">
+              <a:buNone/>
+            </a:pPr>
+            <a:r>
+              <a:rPr lang="en-US" sz="1300" dirty="0">
+                <a:solidFill>
+                  <a:srgbClr val="111111"/>
+                </a:solidFill>
+                <a:latin typeface="Arial" pitchFamily="34" charset="0"/>
+                <a:ea typeface="Arial" pitchFamily="34" charset="-122"/>
+                <a:cs typeface="Arial" pitchFamily="34" charset="-120"/>
+              </a:rPr>
+              <a:t>Cordón negro</a:t>
+            </a:r>
+            <a:endParaRPr lang="en-US" sz="1300" dirty="0"/>
+          </a:p>
+        </p:txBody>
+      </p:sp>
+    </p:spTree>
+  </p:cSld>
+  <p:clrMapOvr>
+    <a:masterClrMapping/>
+  </p:clrMapOvr>
+</p:sld>
+</file>
+
+<file path=ppt/slides/slide13.xml><?xml version="1.0" encoding="utf-8"?>
+<p:sld xmlns:a="http://schemas.openxmlformats.org/drawingml/2006/main" xmlns:r="http://schemas.openxmlformats.org/officeDocument/2006/relationships" xmlns:p="http://schemas.openxmlformats.org/presentationml/2006/main">
+  <p:cSld name="Slide 13">
+    <p:bg>
+      <p:bgPr>
+        <a:solidFill>
+          <a:srgbClr val="FFFFFF"/>
+        </a:solidFill>
+      </p:bgPr>
+    </p:bg>
+    <p:spTree>
+      <p:nvGrpSpPr>
+        <p:cNvPr id="1" name=""/>
+        <p:cNvGrpSpPr/>
+        <p:nvPr/>
+      </p:nvGrpSpPr>
+      <p:grpSpPr>
+        <a:xfrm>
+          <a:off x="0" y="0"/>
+          <a:ext cx="0" cy="0"/>
+          <a:chOff x="0" y="0"/>
+          <a:chExt cx="0" cy="0"/>
+        </a:xfrm>
+      </p:grpSpPr>
+      <p:sp>
+        <p:nvSpPr>
+          <p:cNvPr id="2" name="Text 0"/>
+          <p:cNvSpPr txBox="1"/>
+          <p:nvPr/>
+        </p:nvSpPr>
+        <p:spPr>
+          <a:xfrm>
+            <a:off x="548640" y="411480"/>
+            <a:ext cx="7315200" cy="640080"/>
+          </a:xfrm>
+          <a:prstGeom prst="rect">
+            <a:avLst/>
+          </a:prstGeom>
+          <a:noFill/>
+          <a:ln/>
+        </p:spPr>
+        <p:txBody>
+          <a:bodyPr wrap="square" lIns="0" tIns="0" rIns="0" bIns="0" rtlCol="0" anchor="t"/>
+          <a:lstStyle/>
+          <a:p>
+            <a:pPr indent="0" marL="0">
+              <a:buNone/>
+            </a:pPr>
+            <a:r>
+              <a:rPr lang="en-US" sz="3600" dirty="0">
+                <a:solidFill>
+                  <a:srgbClr val="111111"/>
+                </a:solidFill>
+                <a:latin typeface="Georgia" pitchFamily="34" charset="0"/>
+                <a:ea typeface="Georgia" pitchFamily="34" charset="-122"/>
+                <a:cs typeface="Georgia" pitchFamily="34" charset="-120"/>
+              </a:rPr>
               <a:t>Referencia rápida</a:t>
             </a:r>
             <a:endParaRPr lang="en-US" sz="3600" dirty="0"/>
@@ -3222,7 +3811,7 @@
       </p:sp>
       <p:graphicFrame>
         <p:nvGraphicFramePr>
-          <p:cNvPr id="13" name="Table 0"/>
+          <p:cNvPr id="14" name="Table 0"/>
           <p:cNvGraphicFramePr>
             <a:graphicFrameLocks noGrp="1"/>
           </p:cNvGraphicFramePr>
@@ -3249,7 +3838,7 @@
                 <a:gridCol w="4876495"/>
                 <a:gridCol w="1463040"/>
               </a:tblGrid>
-              <a:tr h="438912">
+              <a:tr h="402336">
                 <a:tc>
                   <a:txBody>
                     <a:bodyPr/>
@@ -3591,7 +4180,7 @@
                   </a:tcPr>
                 </a:tc>
               </a:tr>
-              <a:tr h="438912">
+              <a:tr h="402336">
                 <a:tc>
                   <a:txBody>
                     <a:bodyPr/>
@@ -3933,7 +4522,7 @@
                   </a:tcPr>
                 </a:tc>
               </a:tr>
-              <a:tr h="438912">
+              <a:tr h="402336">
                 <a:tc>
                   <a:txBody>
                     <a:bodyPr/>
@@ -4275,7 +4864,7 @@
                   </a:tcPr>
                 </a:tc>
               </a:tr>
-              <a:tr h="438912">
+              <a:tr h="402336">
                 <a:tc>
                   <a:txBody>
                     <a:bodyPr/>
@@ -4617,7 +5206,7 @@
                   </a:tcPr>
                 </a:tc>
               </a:tr>
-              <a:tr h="438912">
+              <a:tr h="402336">
                 <a:tc>
                   <a:txBody>
                     <a:bodyPr/>
@@ -4959,7 +5548,7 @@
                   </a:tcPr>
                 </a:tc>
               </a:tr>
-              <a:tr h="438912">
+              <a:tr h="402336">
                 <a:tc>
                   <a:txBody>
                     <a:bodyPr/>
@@ -5301,7 +5890,7 @@
                   </a:tcPr>
                 </a:tc>
               </a:tr>
-              <a:tr h="438912">
+              <a:tr h="402336">
                 <a:tc>
                   <a:txBody>
                     <a:bodyPr/>
@@ -5643,7 +6232,7 @@
                   </a:tcPr>
                 </a:tc>
               </a:tr>
-              <a:tr h="438912">
+              <a:tr h="402336">
                 <a:tc>
                   <a:txBody>
                     <a:bodyPr/>
@@ -5985,7 +6574,7 @@
                   </a:tcPr>
                 </a:tc>
               </a:tr>
-              <a:tr h="438912">
+              <a:tr h="402336">
                 <a:tc>
                   <a:txBody>
                     <a:bodyPr/>
@@ -6327,7 +6916,7 @@
                   </a:tcPr>
                 </a:tc>
               </a:tr>
-              <a:tr h="438912">
+              <a:tr h="402336">
                 <a:tc>
                   <a:txBody>
                     <a:bodyPr/>
@@ -6669,6 +7258,348 @@
                   </a:tcPr>
                 </a:tc>
               </a:tr>
+              <a:tr h="402336">
+                <a:tc>
+                  <a:txBody>
+                    <a:bodyPr/>
+                    <a:lstStyle/>
+                    <a:p>
+                      <a:pPr indent="0" marL="0">
+                        <a:buNone/>
+                      </a:pPr>
+                      <a:r>
+                        <a:rPr lang="en-US" sz="1200" dirty="0">
+                          <a:solidFill>
+                            <a:srgbClr val="6B6B6B"/>
+                          </a:solidFill>
+                          <a:latin typeface="Arial" pitchFamily="34" charset="0"/>
+                          <a:ea typeface="Arial" pitchFamily="34" charset="-122"/>
+                          <a:cs typeface="Arial" pitchFamily="34" charset="-120"/>
+                        </a:rPr>
+                        <a:t>10</a:t>
+                      </a:r>
+                      <a:endParaRPr lang="en-US" sz="1200" dirty="0">
+                        <a:latin typeface="Arial" charset="0"/>
+                        <a:ea typeface="Arial" charset="0"/>
+                        <a:cs typeface="Arial" charset="0"/>
+                      </a:endParaRPr>
+                    </a:p>
+                  </a:txBody>
+                  <a:tcPr marL="109728" marR="109728" marT="36576" marB="36576" anchor="ctr">
+                    <a:lnL w="6350" cap="flat" cmpd="sng" algn="ctr">
+                      <a:solidFill>
+                        <a:srgbClr val="DDDDDD"/>
+                      </a:solidFill>
+                      <a:prstDash val="solid"/>
+                      <a:round/>
+                      <a:headEnd type="none" w="med" len="med"/>
+                      <a:tailEnd type="none" w="med" len="med"/>
+                    </a:lnL>
+                    <a:lnR w="6350" cap="flat" cmpd="sng" algn="ctr">
+                      <a:solidFill>
+                        <a:srgbClr val="DDDDDD"/>
+                      </a:solidFill>
+                      <a:prstDash val="solid"/>
+                      <a:round/>
+                      <a:headEnd type="none" w="med" len="med"/>
+                      <a:tailEnd type="none" w="med" len="med"/>
+                    </a:lnR>
+                    <a:lnT w="6350" cap="flat" cmpd="sng" algn="ctr">
+                      <a:solidFill>
+                        <a:srgbClr val="DDDDDD"/>
+                      </a:solidFill>
+                      <a:prstDash val="solid"/>
+                      <a:round/>
+                      <a:headEnd type="none" w="med" len="med"/>
+                      <a:tailEnd type="none" w="med" len="med"/>
+                    </a:lnT>
+                    <a:lnB w="6350" cap="flat" cmpd="sng" algn="ctr">
+                      <a:solidFill>
+                        <a:srgbClr val="DDDDDD"/>
+                      </a:solidFill>
+                      <a:prstDash val="solid"/>
+                      <a:round/>
+                      <a:headEnd type="none" w="med" len="med"/>
+                      <a:tailEnd type="none" w="med" len="med"/>
+                    </a:lnB>
+                    <a:solidFill>
+                      <a:srgbClr val="F3F3F3"/>
+                    </a:solidFill>
+                  </a:tcPr>
+                </a:tc>
+                <a:tc>
+                  <a:txBody>
+                    <a:bodyPr/>
+                    <a:lstStyle/>
+                    <a:p>
+                      <a:pPr indent="0" marL="0">
+                        <a:buNone/>
+                      </a:pPr>
+                      <a:r>
+                        <a:rPr lang="en-US" sz="1200" b="1" dirty="0">
+                          <a:solidFill>
+                            <a:srgbClr val="111111"/>
+                          </a:solidFill>
+                          <a:latin typeface="Arial" pitchFamily="34" charset="0"/>
+                          <a:ea typeface="Arial" pitchFamily="34" charset="-122"/>
+                          <a:cs typeface="Arial" pitchFamily="34" charset="-120"/>
+                        </a:rPr>
+                        <a:t>Monograma claro</a:t>
+                      </a:r>
+                      <a:endParaRPr lang="en-US" sz="1200" dirty="0">
+                        <a:latin typeface="Arial" charset="0"/>
+                        <a:ea typeface="Arial" charset="0"/>
+                        <a:cs typeface="Arial" charset="0"/>
+                      </a:endParaRPr>
+                    </a:p>
+                  </a:txBody>
+                  <a:tcPr marL="109728" marR="109728" marT="36576" marB="36576" anchor="ctr">
+                    <a:lnL w="6350" cap="flat" cmpd="sng" algn="ctr">
+                      <a:solidFill>
+                        <a:srgbClr val="DDDDDD"/>
+                      </a:solidFill>
+                      <a:prstDash val="solid"/>
+                      <a:round/>
+                      <a:headEnd type="none" w="med" len="med"/>
+                      <a:tailEnd type="none" w="med" len="med"/>
+                    </a:lnL>
+                    <a:lnR w="6350" cap="flat" cmpd="sng" algn="ctr">
+                      <a:solidFill>
+                        <a:srgbClr val="DDDDDD"/>
+                      </a:solidFill>
+                      <a:prstDash val="solid"/>
+                      <a:round/>
+                      <a:headEnd type="none" w="med" len="med"/>
+                      <a:tailEnd type="none" w="med" len="med"/>
+                    </a:lnR>
+                    <a:lnT w="6350" cap="flat" cmpd="sng" algn="ctr">
+                      <a:solidFill>
+                        <a:srgbClr val="DDDDDD"/>
+                      </a:solidFill>
+                      <a:prstDash val="solid"/>
+                      <a:round/>
+                      <a:headEnd type="none" w="med" len="med"/>
+                      <a:tailEnd type="none" w="med" len="med"/>
+                    </a:lnT>
+                    <a:lnB w="6350" cap="flat" cmpd="sng" algn="ctr">
+                      <a:solidFill>
+                        <a:srgbClr val="DDDDDD"/>
+                      </a:solidFill>
+                      <a:prstDash val="solid"/>
+                      <a:round/>
+                      <a:headEnd type="none" w="med" len="med"/>
+                      <a:tailEnd type="none" w="med" len="med"/>
+                    </a:lnB>
+                    <a:solidFill>
+                      <a:srgbClr val="F3F3F3"/>
+                    </a:solidFill>
+                  </a:tcPr>
+                </a:tc>
+                <a:tc>
+                  <a:txBody>
+                    <a:bodyPr/>
+                    <a:lstStyle/>
+                    <a:p>
+                      <a:pPr indent="0" marL="0">
+                        <a:buNone/>
+                      </a:pPr>
+                      <a:r>
+                        <a:rPr lang="en-US" sz="1200" dirty="0">
+                          <a:solidFill>
+                            <a:srgbClr val="111111"/>
+                          </a:solidFill>
+                          <a:latin typeface="Arial" pitchFamily="34" charset="0"/>
+                          <a:ea typeface="Arial" pitchFamily="34" charset="-122"/>
+                          <a:cs typeface="Arial" pitchFamily="34" charset="-120"/>
+                        </a:rPr>
+                        <a:t>Blanca</a:t>
+                      </a:r>
+                      <a:endParaRPr lang="en-US" sz="1200" dirty="0">
+                        <a:latin typeface="Arial" charset="0"/>
+                        <a:ea typeface="Arial" charset="0"/>
+                        <a:cs typeface="Arial" charset="0"/>
+                      </a:endParaRPr>
+                    </a:p>
+                  </a:txBody>
+                  <a:tcPr marL="109728" marR="109728" marT="36576" marB="36576" anchor="ctr">
+                    <a:lnL w="6350" cap="flat" cmpd="sng" algn="ctr">
+                      <a:solidFill>
+                        <a:srgbClr val="DDDDDD"/>
+                      </a:solidFill>
+                      <a:prstDash val="solid"/>
+                      <a:round/>
+                      <a:headEnd type="none" w="med" len="med"/>
+                      <a:tailEnd type="none" w="med" len="med"/>
+                    </a:lnL>
+                    <a:lnR w="6350" cap="flat" cmpd="sng" algn="ctr">
+                      <a:solidFill>
+                        <a:srgbClr val="DDDDDD"/>
+                      </a:solidFill>
+                      <a:prstDash val="solid"/>
+                      <a:round/>
+                      <a:headEnd type="none" w="med" len="med"/>
+                      <a:tailEnd type="none" w="med" len="med"/>
+                    </a:lnR>
+                    <a:lnT w="6350" cap="flat" cmpd="sng" algn="ctr">
+                      <a:solidFill>
+                        <a:srgbClr val="DDDDDD"/>
+                      </a:solidFill>
+                      <a:prstDash val="solid"/>
+                      <a:round/>
+                      <a:headEnd type="none" w="med" len="med"/>
+                      <a:tailEnd type="none" w="med" len="med"/>
+                    </a:lnT>
+                    <a:lnB w="6350" cap="flat" cmpd="sng" algn="ctr">
+                      <a:solidFill>
+                        <a:srgbClr val="DDDDDD"/>
+                      </a:solidFill>
+                      <a:prstDash val="solid"/>
+                      <a:round/>
+                      <a:headEnd type="none" w="med" len="med"/>
+                      <a:tailEnd type="none" w="med" len="med"/>
+                    </a:lnB>
+                    <a:solidFill>
+                      <a:srgbClr val="F3F3F3"/>
+                    </a:solidFill>
+                  </a:tcPr>
+                </a:tc>
+                <a:tc>
+                  <a:txBody>
+                    <a:bodyPr/>
+                    <a:lstStyle/>
+                    <a:p>
+                      <a:pPr indent="0" marL="0">
+                        <a:buNone/>
+                      </a:pPr>
+                      <a:r>
+                        <a:rPr lang="en-US" sz="1200" dirty="0">
+                          <a:solidFill>
+                            <a:srgbClr val="111111"/>
+                          </a:solidFill>
+                          <a:latin typeface="Arial" pitchFamily="34" charset="0"/>
+                          <a:ea typeface="Arial" pitchFamily="34" charset="-122"/>
+                          <a:cs typeface="Arial" pitchFamily="34" charset="-120"/>
+                        </a:rPr>
+                        <a:t>Negro y gris claro (trama del negro)</a:t>
+                      </a:r>
+                      <a:endParaRPr lang="en-US" sz="1200" dirty="0">
+                        <a:latin typeface="Arial" charset="0"/>
+                        <a:ea typeface="Arial" charset="0"/>
+                        <a:cs typeface="Arial" charset="0"/>
+                      </a:endParaRPr>
+                    </a:p>
+                  </a:txBody>
+                  <a:tcPr marL="109728" marR="109728" marT="36576" marB="36576" anchor="ctr">
+                    <a:lnL w="6350" cap="flat" cmpd="sng" algn="ctr">
+                      <a:solidFill>
+                        <a:srgbClr val="DDDDDD"/>
+                      </a:solidFill>
+                      <a:prstDash val="solid"/>
+                      <a:round/>
+                      <a:headEnd type="none" w="med" len="med"/>
+                      <a:tailEnd type="none" w="med" len="med"/>
+                    </a:lnL>
+                    <a:lnR w="6350" cap="flat" cmpd="sng" algn="ctr">
+                      <a:solidFill>
+                        <a:srgbClr val="DDDDDD"/>
+                      </a:solidFill>
+                      <a:prstDash val="solid"/>
+                      <a:round/>
+                      <a:headEnd type="none" w="med" len="med"/>
+                      <a:tailEnd type="none" w="med" len="med"/>
+                    </a:lnR>
+                    <a:lnT w="6350" cap="flat" cmpd="sng" algn="ctr">
+                      <a:solidFill>
+                        <a:srgbClr val="DDDDDD"/>
+                      </a:solidFill>
+                      <a:prstDash val="solid"/>
+                      <a:round/>
+                      <a:headEnd type="none" w="med" len="med"/>
+                      <a:tailEnd type="none" w="med" len="med"/>
+                    </a:lnT>
+                    <a:lnB w="6350" cap="flat" cmpd="sng" algn="ctr">
+                      <a:solidFill>
+                        <a:srgbClr val="DDDDDD"/>
+                      </a:solidFill>
+                      <a:prstDash val="solid"/>
+                      <a:round/>
+                      <a:headEnd type="none" w="med" len="med"/>
+                      <a:tailEnd type="none" w="med" len="med"/>
+                    </a:lnB>
+                    <a:solidFill>
+                      <a:srgbClr val="F3F3F3"/>
+                    </a:solidFill>
+                  </a:tcPr>
+                </a:tc>
+                <a:tc>
+                  <a:txBody>
+                    <a:bodyPr/>
+                    <a:lstStyle/>
+                    <a:p>
+                      <a:pPr indent="0" marL="0">
+                        <a:buNone/>
+                      </a:pPr>
+                      <a:r>
+                        <a:rPr lang="en-US" sz="1200" dirty="0">
+                          <a:solidFill>
+                            <a:srgbClr val="111111"/>
+                          </a:solidFill>
+                          <a:latin typeface="Arial" pitchFamily="34" charset="0"/>
+                          <a:ea typeface="Arial" pitchFamily="34" charset="-122"/>
+                          <a:cs typeface="Arial" pitchFamily="34" charset="-120"/>
+                        </a:rPr>
+                        <a:t>Baja</a:t>
+                      </a:r>
+                      <a:endParaRPr lang="en-US" sz="1200" dirty="0">
+                        <a:latin typeface="Arial" charset="0"/>
+                        <a:ea typeface="Arial" charset="0"/>
+                        <a:cs typeface="Arial" charset="0"/>
+                      </a:endParaRPr>
+                    </a:p>
+                  </a:txBody>
+                  <a:tcPr marL="109728" marR="109728" marT="36576" marB="36576" anchor="ctr">
+                    <a:lnL w="6350" cap="flat" cmpd="sng" algn="ctr">
+                      <a:solidFill>
+                        <a:srgbClr val="DDDDDD"/>
+                      </a:solidFill>
+                      <a:prstDash val="solid"/>
+                      <a:round/>
+                      <a:headEnd type="none" w="med" len="med"/>
+                      <a:tailEnd type="none" w="med" len="med"/>
+                    </a:lnL>
+                    <a:lnR w="6350" cap="flat" cmpd="sng" algn="ctr">
+                      <a:solidFill>
+                        <a:srgbClr val="DDDDDD"/>
+                      </a:solidFill>
+                      <a:prstDash val="solid"/>
+                      <a:round/>
+                      <a:headEnd type="none" w="med" len="med"/>
+                      <a:tailEnd type="none" w="med" len="med"/>
+                    </a:lnR>
+                    <a:lnT w="6350" cap="flat" cmpd="sng" algn="ctr">
+                      <a:solidFill>
+                        <a:srgbClr val="DDDDDD"/>
+                      </a:solidFill>
+                      <a:prstDash val="solid"/>
+                      <a:round/>
+                      <a:headEnd type="none" w="med" len="med"/>
+                      <a:tailEnd type="none" w="med" len="med"/>
+                    </a:lnT>
+                    <a:lnB w="6350" cap="flat" cmpd="sng" algn="ctr">
+                      <a:solidFill>
+                        <a:srgbClr val="DDDDDD"/>
+                      </a:solidFill>
+                      <a:prstDash val="solid"/>
+                      <a:round/>
+                      <a:headEnd type="none" w="med" len="med"/>
+                      <a:tailEnd type="none" w="med" len="med"/>
+                    </a:lnB>
+                    <a:solidFill>
+                      <a:srgbClr val="F3F3F3"/>
+                    </a:solidFill>
+                  </a:tcPr>
+                </a:tc>
+              </a:tr>
             </a:tbl>
           </a:graphicData>
         </a:graphic>
@@ -6720,9 +7651,9 @@
 </p:sld>
 </file>
 
-<file path=ppt/slides/slide13.xml><?xml version="1.0" encoding="utf-8"?>
+<file path=ppt/slides/slide14.xml><?xml version="1.0" encoding="utf-8"?>
 <p:sld xmlns:a="http://schemas.openxmlformats.org/drawingml/2006/main" xmlns:r="http://schemas.openxmlformats.org/officeDocument/2006/relationships" xmlns:p="http://schemas.openxmlformats.org/presentationml/2006/main">
-  <p:cSld name="Slide 13">
+  <p:cSld name="Slide 14">
     <p:bg>
       <p:bgPr>
         <a:solidFill>
@@ -7405,7 +8336,7 @@
                 <a:ea typeface="Georgia" pitchFamily="34" charset="-122"/>
                 <a:cs typeface="Georgia" pitchFamily="34" charset="-120"/>
               </a:rPr>
-              <a:t>Nueve propuestas</a:t>
+              <a:t>Diez propuestas</a:t>
             </a:r>
             <a:endParaRPr lang="en-US" sz="3600" dirty="0"/>
           </a:p>
@@ -7851,7 +8782,7 @@
         </p:blipFill>
         <p:spPr>
           <a:xfrm>
-            <a:off x="2312060" y="4069080"/>
+            <a:off x="1308964" y="4069080"/>
             <a:ext cx="1548994" cy="2011680"/>
           </a:xfrm>
           <a:prstGeom prst="rect">
@@ -7867,7 +8798,7 @@
         </p:nvSpPr>
         <p:spPr>
           <a:xfrm>
-            <a:off x="2312060" y="6135624"/>
+            <a:off x="1308964" y="6135624"/>
             <a:ext cx="1914754" cy="256032"/>
           </a:xfrm>
           <a:prstGeom prst="rect">
@@ -7928,7 +8859,7 @@
         </p:blipFill>
         <p:spPr>
           <a:xfrm>
-            <a:off x="4318254" y="4069080"/>
+            <a:off x="3315157" y="4069080"/>
             <a:ext cx="1548994" cy="2011680"/>
           </a:xfrm>
           <a:prstGeom prst="rect">
@@ -7944,7 +8875,7 @@
         </p:nvSpPr>
         <p:spPr>
           <a:xfrm>
-            <a:off x="4318254" y="6135624"/>
+            <a:off x="3315157" y="6135624"/>
             <a:ext cx="1914754" cy="256032"/>
           </a:xfrm>
           <a:prstGeom prst="rect">
@@ -8005,7 +8936,7 @@
         </p:blipFill>
         <p:spPr>
           <a:xfrm>
-            <a:off x="6324448" y="4069080"/>
+            <a:off x="5321351" y="4069080"/>
             <a:ext cx="1548994" cy="2011680"/>
           </a:xfrm>
           <a:prstGeom prst="rect">
@@ -8021,7 +8952,7 @@
         </p:nvSpPr>
         <p:spPr>
           <a:xfrm>
-            <a:off x="6324448" y="6135624"/>
+            <a:off x="5321351" y="6135624"/>
             <a:ext cx="1914754" cy="256032"/>
           </a:xfrm>
           <a:prstGeom prst="rect">
@@ -8082,7 +9013,7 @@
         </p:blipFill>
         <p:spPr>
           <a:xfrm>
-            <a:off x="8330641" y="4069080"/>
+            <a:off x="7327544" y="4069080"/>
             <a:ext cx="1548994" cy="2011680"/>
           </a:xfrm>
           <a:prstGeom prst="rect">
@@ -8098,7 +9029,7 @@
         </p:nvSpPr>
         <p:spPr>
           <a:xfrm>
-            <a:off x="8330641" y="6135624"/>
+            <a:off x="7327544" y="6135624"/>
             <a:ext cx="1914754" cy="256032"/>
           </a:xfrm>
           <a:prstGeom prst="rect">
@@ -8138,6 +9069,83 @@
                 <a:cs typeface="Arial" pitchFamily="34" charset="-120"/>
               </a:rPr>
               <a:t>Reverso</a:t>
+            </a:r>
+            <a:endParaRPr lang="en-US" sz="1100" dirty="0"/>
+          </a:p>
+        </p:txBody>
+      </p:sp>
+      <p:pic>
+        <p:nvPicPr>
+          <p:cNvPr id="22" name="Image 9" descr="Propuesta 10: Monograma claro">    </p:cNvPr>
+          <p:cNvPicPr>
+            <a:picLocks noChangeAspect="1"/>
+          </p:cNvPicPr>
+          <p:nvPr/>
+        </p:nvPicPr>
+        <p:blipFill>
+          <a:blip r:embed="rId10"/>
+          <a:stretch>
+            <a:fillRect/>
+          </a:stretch>
+        </p:blipFill>
+        <p:spPr>
+          <a:xfrm>
+            <a:off x="9333738" y="4069080"/>
+            <a:ext cx="1548994" cy="2011680"/>
+          </a:xfrm>
+          <a:prstGeom prst="rect">
+            <a:avLst/>
+          </a:prstGeom>
+        </p:spPr>
+      </p:pic>
+      <p:sp>
+        <p:nvSpPr>
+          <p:cNvPr id="23" name="Text 11"/>
+          <p:cNvSpPr txBox="1"/>
+          <p:nvPr/>
+        </p:nvSpPr>
+        <p:spPr>
+          <a:xfrm>
+            <a:off x="9333738" y="6135624"/>
+            <a:ext cx="1914754" cy="256032"/>
+          </a:xfrm>
+          <a:prstGeom prst="rect">
+            <a:avLst/>
+          </a:prstGeom>
+          <a:noFill/>
+          <a:ln/>
+        </p:spPr>
+        <p:txBody>
+          <a:bodyPr wrap="square" lIns="0" tIns="0" rIns="0" bIns="0" rtlCol="0" anchor="t"/>
+          <a:lstStyle/>
+          <a:p>
+            <a:pPr indent="0" marL="0">
+              <a:buNone/>
+            </a:pPr>
+            <a:r>
+              <a:rPr lang="en-US" sz="1100" b="1" dirty="0">
+                <a:solidFill>
+                  <a:srgbClr val="111111"/>
+                </a:solidFill>
+                <a:latin typeface="Arial" pitchFamily="34" charset="0"/>
+                <a:ea typeface="Arial" pitchFamily="34" charset="-122"/>
+                <a:cs typeface="Arial" pitchFamily="34" charset="-120"/>
+              </a:rPr>
+              <a:t>10  </a:t>
+            </a:r>
+            <a:pPr indent="0" marL="0">
+              <a:buNone/>
+            </a:pPr>
+            <a:r>
+              <a:rPr lang="en-US" sz="1100" dirty="0">
+                <a:solidFill>
+                  <a:srgbClr val="111111"/>
+                </a:solidFill>
+                <a:latin typeface="Arial" pitchFamily="34" charset="0"/>
+                <a:ea typeface="Arial" pitchFamily="34" charset="-122"/>
+                <a:cs typeface="Arial" pitchFamily="34" charset="-120"/>
+              </a:rPr>
+              <a:t>Monograma claro</a:t>
             </a:r>
             <a:endParaRPr lang="en-US" sz="1100" dirty="0"/>
           </a:p>

</xml_diff>